<commit_message>
feat(text): resize unwrapped spAutoFit shapes to their text width (#77)
When a text body has wrap="none" and spAutoFit, set the shape width to the
widest line plus insets and keep the edge on the first paragraph's
alignment side fixed (left, centre, right), following the text's own
direction through rotation and flips. Bodies without visible text, table
cells, and vertical text keep their saved width; the "only height is
expanded" diagnostic is gone.

Add a page with too-narrow and too-wide labels to the text-autofit
fixture and record the LibreOffice difference in docs/rendering.md.

Claude-Session: https://claude.ai/code/session_01WPGucr2TUYsgYFqzbQRj3u
</commit_message>
<xml_diff>
--- a/examples/text-autofit.pptx
+++ b/examples/text-autofit.pptx
@@ -9,6 +9,7 @@
     <p:sldId id="257" r:id="rId8"/>
     <p:sldId id="258" r:id="rId9"/>
     <p:sldId id="259" r:id="rId10"/>
+    <p:sldId id="260" r:id="rId11"/>
   </p:sldIdLst>
   <p:sldSz cx="5486400" cy="3200400" type="screen4x3"/>
   <p:notesSz cx="6858000" cy="9144000"/>
@@ -3636,6 +3637,276 @@
                 <a:latin typeface="Arial"/>
               </a:rPr>
               <a:t>Expand 3</a:t>
+            </a:r>
+          </a:p>
+        </p:txBody>
+      </p:sp>
+    </p:spTree>
+  </p:cSld>
+  <p:clrMapOvr>
+    <a:masterClrMapping/>
+  </p:clrMapOvr>
+</p:sld>
+</file>
+
+<file path=ppt/slides/slide5.xml><?xml version="1.0" encoding="utf-8"?>
+<p:sld xmlns:a="http://schemas.openxmlformats.org/drawingml/2006/main" xmlns:p="http://schemas.openxmlformats.org/presentationml/2006/main" xmlns:r="http://schemas.openxmlformats.org/officeDocument/2006/relationships">
+  <p:cSld>
+    <p:spTree>
+      <p:nvGrpSpPr>
+        <p:cNvPr id="1" name=""/>
+        <p:cNvGrpSpPr/>
+        <p:nvPr/>
+      </p:nvGrpSpPr>
+      <p:grpSpPr/>
+      <p:sp>
+        <p:nvSpPr>
+          <p:cNvPr id="2" name="Rectangle 1"/>
+          <p:cNvSpPr/>
+          <p:nvPr/>
+        </p:nvSpPr>
+        <p:spPr>
+          <a:xfrm>
+            <a:off x="777240" y="548640"/>
+            <a:ext cx="548640" cy="457200"/>
+          </a:xfrm>
+          <a:prstGeom prst="rect">
+            <a:avLst/>
+          </a:prstGeom>
+          <a:solidFill>
+            <a:srgbClr val="E6F0FF"/>
+          </a:solidFill>
+          <a:ln w="12700">
+            <a:solidFill>
+              <a:srgbClr val="2850A0"/>
+            </a:solidFill>
+          </a:ln>
+        </p:spPr>
+        <p:txBody>
+          <a:bodyPr rtlCol="0" anchor="ctr" wrap="none" tIns="50800" bIns="50800" lIns="76200" rIns="76200">
+            <a:spAutoFit/>
+          </a:bodyPr>
+          <a:lstStyle/>
+          <a:p>
+            <a:pPr algn="l"/>
+            <a:r>
+              <a:rPr sz="1800">
+                <a:solidFill>
+                  <a:srgbClr val="000000"/>
+                </a:solidFill>
+                <a:latin typeface="Arial"/>
+              </a:rPr>
+              <a:t>Label L</a:t>
+            </a:r>
+          </a:p>
+        </p:txBody>
+      </p:sp>
+      <p:sp>
+        <p:nvSpPr>
+          <p:cNvPr id="3" name="Rectangle 2"/>
+          <p:cNvSpPr/>
+          <p:nvPr/>
+        </p:nvSpPr>
+        <p:spPr>
+          <a:xfrm>
+            <a:off x="2514600" y="548640"/>
+            <a:ext cx="548640" cy="457200"/>
+          </a:xfrm>
+          <a:prstGeom prst="rect">
+            <a:avLst/>
+          </a:prstGeom>
+          <a:solidFill>
+            <a:srgbClr val="E6F0FF"/>
+          </a:solidFill>
+          <a:ln w="12700">
+            <a:solidFill>
+              <a:srgbClr val="2850A0"/>
+            </a:solidFill>
+          </a:ln>
+        </p:spPr>
+        <p:txBody>
+          <a:bodyPr rtlCol="0" anchor="ctr" wrap="none" tIns="50800" bIns="50800" lIns="76200" rIns="76200">
+            <a:spAutoFit/>
+          </a:bodyPr>
+          <a:lstStyle/>
+          <a:p>
+            <a:pPr algn="ctr"/>
+            <a:r>
+              <a:rPr sz="1800">
+                <a:solidFill>
+                  <a:srgbClr val="000000"/>
+                </a:solidFill>
+                <a:latin typeface="Arial"/>
+              </a:rPr>
+              <a:t>Label C</a:t>
+            </a:r>
+          </a:p>
+        </p:txBody>
+      </p:sp>
+      <p:sp>
+        <p:nvSpPr>
+          <p:cNvPr id="4" name="Rectangle 3"/>
+          <p:cNvSpPr/>
+          <p:nvPr/>
+        </p:nvSpPr>
+        <p:spPr>
+          <a:xfrm>
+            <a:off x="4251959" y="548640"/>
+            <a:ext cx="548640" cy="457200"/>
+          </a:xfrm>
+          <a:prstGeom prst="rect">
+            <a:avLst/>
+          </a:prstGeom>
+          <a:solidFill>
+            <a:srgbClr val="E6F0FF"/>
+          </a:solidFill>
+          <a:ln w="12700">
+            <a:solidFill>
+              <a:srgbClr val="2850A0"/>
+            </a:solidFill>
+          </a:ln>
+        </p:spPr>
+        <p:txBody>
+          <a:bodyPr rtlCol="0" anchor="ctr" wrap="none" tIns="50800" bIns="50800" lIns="76200" rIns="76200">
+            <a:spAutoFit/>
+          </a:bodyPr>
+          <a:lstStyle/>
+          <a:p>
+            <a:pPr algn="r"/>
+            <a:r>
+              <a:rPr sz="1800">
+                <a:solidFill>
+                  <a:srgbClr val="000000"/>
+                </a:solidFill>
+                <a:latin typeface="Arial"/>
+              </a:rPr>
+              <a:t>Label R</a:t>
+            </a:r>
+          </a:p>
+        </p:txBody>
+      </p:sp>
+      <p:sp>
+        <p:nvSpPr>
+          <p:cNvPr id="5" name="Rectangle 4"/>
+          <p:cNvSpPr/>
+          <p:nvPr/>
+        </p:nvSpPr>
+        <p:spPr>
+          <a:xfrm>
+            <a:off x="274320" y="1828800"/>
+            <a:ext cx="1554480" cy="457200"/>
+          </a:xfrm>
+          <a:prstGeom prst="rect">
+            <a:avLst/>
+          </a:prstGeom>
+          <a:solidFill>
+            <a:srgbClr val="E6F0FF"/>
+          </a:solidFill>
+          <a:ln w="12700">
+            <a:solidFill>
+              <a:srgbClr val="2850A0"/>
+            </a:solidFill>
+          </a:ln>
+        </p:spPr>
+        <p:txBody>
+          <a:bodyPr rtlCol="0" anchor="ctr" wrap="none" tIns="50800" bIns="50800" lIns="76200" rIns="76200">
+            <a:spAutoFit/>
+          </a:bodyPr>
+          <a:lstStyle/>
+          <a:p>
+            <a:pPr algn="l"/>
+            <a:r>
+              <a:rPr sz="1800">
+                <a:solidFill>
+                  <a:srgbClr val="000000"/>
+                </a:solidFill>
+                <a:latin typeface="Arial"/>
+              </a:rPr>
+              <a:t>Label L</a:t>
+            </a:r>
+          </a:p>
+        </p:txBody>
+      </p:sp>
+      <p:sp>
+        <p:nvSpPr>
+          <p:cNvPr id="6" name="Rectangle 5"/>
+          <p:cNvSpPr/>
+          <p:nvPr/>
+        </p:nvSpPr>
+        <p:spPr>
+          <a:xfrm>
+            <a:off x="2011679" y="1828800"/>
+            <a:ext cx="1554480" cy="457200"/>
+          </a:xfrm>
+          <a:prstGeom prst="rect">
+            <a:avLst/>
+          </a:prstGeom>
+          <a:solidFill>
+            <a:srgbClr val="E6F0FF"/>
+          </a:solidFill>
+          <a:ln w="12700">
+            <a:solidFill>
+              <a:srgbClr val="2850A0"/>
+            </a:solidFill>
+          </a:ln>
+        </p:spPr>
+        <p:txBody>
+          <a:bodyPr rtlCol="0" anchor="ctr" wrap="none" tIns="50800" bIns="50800" lIns="76200" rIns="76200">
+            <a:spAutoFit/>
+          </a:bodyPr>
+          <a:lstStyle/>
+          <a:p>
+            <a:pPr algn="ctr"/>
+            <a:r>
+              <a:rPr sz="1800">
+                <a:solidFill>
+                  <a:srgbClr val="000000"/>
+                </a:solidFill>
+                <a:latin typeface="Arial"/>
+              </a:rPr>
+              <a:t>Label C</a:t>
+            </a:r>
+          </a:p>
+        </p:txBody>
+      </p:sp>
+      <p:sp>
+        <p:nvSpPr>
+          <p:cNvPr id="7" name="Rectangle 6"/>
+          <p:cNvSpPr/>
+          <p:nvPr/>
+        </p:nvSpPr>
+        <p:spPr>
+          <a:xfrm>
+            <a:off x="3749039" y="1828800"/>
+            <a:ext cx="1554480" cy="457200"/>
+          </a:xfrm>
+          <a:prstGeom prst="rect">
+            <a:avLst/>
+          </a:prstGeom>
+          <a:solidFill>
+            <a:srgbClr val="E6F0FF"/>
+          </a:solidFill>
+          <a:ln w="12700">
+            <a:solidFill>
+              <a:srgbClr val="2850A0"/>
+            </a:solidFill>
+          </a:ln>
+        </p:spPr>
+        <p:txBody>
+          <a:bodyPr rtlCol="0" anchor="ctr" wrap="none" tIns="50800" bIns="50800" lIns="76200" rIns="76200">
+            <a:spAutoFit/>
+          </a:bodyPr>
+          <a:lstStyle/>
+          <a:p>
+            <a:pPr algn="r"/>
+            <a:r>
+              <a:rPr sz="1800">
+                <a:solidFill>
+                  <a:srgbClr val="000000"/>
+                </a:solidFill>
+                <a:latin typeface="Arial"/>
+              </a:rPr>
+              <a:t>Label R</a:t>
             </a:r>
           </a:p>
         </p:txBody>

</xml_diff>